<commit_message>
Week 8: midterm format is Vietnamese-first with Chinese alongside; mock exam, L3 slides and handouts updated
Co-Authored-By: Claude Opus 5.5 <noreply@anthropic.com>
</commit_message>
<xml_diff>
--- a/第八週(10-29)/第八週_第3節_簡報.pptx
+++ b/第八週(10-29)/第八週_第3節_簡報.pptx
@@ -508,7 +508,7 @@
                 <a:ea typeface="Arial Unicode MS"/>
                 <a:cs typeface="Arial Unicode MS"/>
               </a:rPr>
-              <a:t>這一節分兩段。前半段，我們一週一週走過去，每一週只講最重要的幾句話和一張表。後半段，大家打開一份模擬考，二十八題，題目跟期中考一樣是中文和英文對照，網頁上可以再打開越南文。做完按交卷，網頁會告訴你哪一週錯得最多，那一週的講義回去再翻一次。
+              <a:t>這一節分兩段。前半段，我們一週一週走過去，每一週只講最重要的幾句話和一張表。後半段，大家打開一份模擬考，二十八題，題目跟期中考一樣是越南文為主、中文對照。做完按交卷，網頁會告訴你哪一週錯得最多，那一週的講義回去再翻一次。
 </a:t>
             </a:r>
           </a:p>
@@ -1817,7 +1817,7 @@
                 <a:ea typeface="Arial Unicode MS"/>
                 <a:cs typeface="Arial Unicode MS"/>
               </a:rPr>
-              <a:t>二十八題，第一週到第八週都有，每一題都是中文加英文，跟期中考一樣。右上角的「Tiếng Việt」按鈕可以開關越南文，建議先關掉，試著讀英文，真的看不懂再打開。
+              <a:t>二十八題，第一週到第八週都有。每一題上面是越南文，下面是中文對照，跟期中考一樣。右上角有一個「English」按鈕，可以再打開英文，平常不用開。
 </a:t>
             </a:r>
           </a:p>
@@ -2653,7 +2653,29 @@
                 <a:ea typeface="Arial Unicode MS"/>
                 <a:cs typeface="Arial Unicode MS"/>
               </a:rPr>
-              <a:t>：題目是中文和英文對照，沒有越南文。所以今天的模擬考，請大家試著讀英文那一行，網頁上越南文可以關掉。
+              <a:t>：題目以</a:t>
+            </a:r>
+            <a:r>
+              <a:rPr sz="1600" b="1" lang="zh-TW" dirty="0">
+                <a:solidFill>
+                  <a:srgbClr val="000000"/>
+                </a:solidFill>
+                <a:latin typeface="Arial Unicode MS"/>
+                <a:ea typeface="Arial Unicode MS"/>
+                <a:cs typeface="Arial Unicode MS"/>
+              </a:rPr>
+              <a:t>越南文為主，旁邊附中文對照</a:t>
+            </a:r>
+            <a:r>
+              <a:rPr sz="1600" lang="zh-TW" dirty="0">
+                <a:solidFill>
+                  <a:srgbClr val="000000"/>
+                </a:solidFill>
+                <a:latin typeface="Arial Unicode MS"/>
+                <a:ea typeface="Arial Unicode MS"/>
+                <a:cs typeface="Arial Unicode MS"/>
+              </a:rPr>
+              <a:t>。今天的模擬考就是這個樣子，大家可以順便練習：越南文看懂了，再對一下中文的關鍵字，例如「門檻」「煞停距離」「外參」，這些中文名詞上課一直在用。
 </a:t>
             </a:r>
           </a:p>
@@ -9717,7 +9739,7 @@
                 <a:ea typeface="Arial" pitchFamily="34" charset="-122"/>
                 <a:cs typeface="Arial" pitchFamily="34" charset="-120"/>
               </a:rPr>
-              <a:t>28 câu, tuần 1–8. Đề song ngữ Trung–Anh; nút «Tiếng Việt» bật/tắt dòng tiếng Việt</a:t>
+              <a:t>28 câu, tuần 1–8. Tiếng Việt là chính, có tiếng Trung đối chiếu (giống đề thi thật)</a:t>
             </a:r>
             <a:endParaRPr lang="en-US" sz="1150" dirty="0"/>
           </a:p>
@@ -9737,7 +9759,7 @@
                 <a:ea typeface="微軟正黑體" pitchFamily="34" charset="-122"/>
                 <a:cs typeface="微軟正黑體" pitchFamily="34" charset="-120"/>
               </a:rPr>
-              <a:t>28 題，第一到八週。中英對照；「Tiếng Việt」鈕開關越南文</a:t>
+              <a:t>28 題，第一到八週。越南文為主、中文對照（跟期中考一樣）</a:t>
             </a:r>
             <a:endParaRPr lang="en-US" sz="1150" dirty="0"/>
           </a:p>
@@ -12174,7 +12196,7 @@
                 <a:ea typeface="Arial" pitchFamily="34" charset="-122"/>
                 <a:cs typeface="Arial" pitchFamily="34" charset="-120"/>
               </a:rPr>
-              <a:t>中 / EN</a:t>
+              <a:t>VI / 中</a:t>
             </a:r>
             <a:endParaRPr lang="en-US" sz="2500" dirty="0"/>
           </a:p>
@@ -12216,7 +12238,7 @@
                 <a:ea typeface="Arial" pitchFamily="34" charset="-122"/>
                 <a:cs typeface="Arial" pitchFamily="34" charset="-120"/>
               </a:rPr>
-              <a:t>song ngữ Trung–Anh</a:t>
+              <a:t>tiếng Việt là chính</a:t>
             </a:r>
             <a:endParaRPr lang="en-US" sz="1250" dirty="0"/>
           </a:p>
@@ -12236,7 +12258,7 @@
                 <a:ea typeface="微軟正黑體" pitchFamily="34" charset="-122"/>
                 <a:cs typeface="微軟正黑體" pitchFamily="34" charset="-120"/>
               </a:rPr>
-              <a:t>中英對照</a:t>
+              <a:t>越南文為主、中文對照</a:t>
             </a:r>
             <a:endParaRPr lang="en-US" sz="1250" dirty="0"/>
           </a:p>
@@ -12278,7 +12300,7 @@
                 <a:ea typeface="Arial" pitchFamily="34" charset="-122"/>
                 <a:cs typeface="Arial" pitchFamily="34" charset="-120"/>
               </a:rPr>
-              <a:t>Đề không có tiếng Việt.</a:t>
+              <a:t>Mỗi câu có tiếng Trung đối chiếu.</a:t>
             </a:r>
             <a:endParaRPr lang="en-US" sz="1100" dirty="0"/>
           </a:p>
@@ -12298,7 +12320,7 @@
                 <a:ea typeface="微軟正黑體" pitchFamily="34" charset="-122"/>
                 <a:cs typeface="微軟正黑體" pitchFamily="34" charset="-120"/>
               </a:rPr>
-              <a:t>考卷沒有越南文。</a:t>
+              <a:t>每一題都附中文對照。</a:t>
             </a:r>
             <a:endParaRPr lang="en-US" sz="1100" dirty="0"/>
           </a:p>

</xml_diff>

<commit_message>
Week 8: explain lx (lux, illuminance) with reference values in L3 slide 5, mock exam and handouts
Co-Authored-By: Claude Opus 5.5 <noreply@anthropic.com>
</commit_message>
<xml_diff>
--- a/第八週(10-29)/第八週_第3節_簡報.pptx
+++ b/第八週(10-29)/第八週_第3節_簡報.pptx
@@ -3895,11 +3895,11 @@
                 <a:spcPts val="0"/>
               </a:spcBef>
               <a:spcAft>
-                <a:spcPts val="267"/>
+                <a:spcPts val="233"/>
               </a:spcAft>
             </a:pPr>
             <a:r>
-              <a:rPr sz="1600" b="1" lang="zh-TW" dirty="0">
+              <a:rPr sz="1400" b="1" lang="zh-TW" dirty="0">
                 <a:solidFill>
                   <a:srgbClr val="000000"/>
                 </a:solidFill>
@@ -3910,7 +3910,7 @@
               <a:t>這一張的目的：</a:t>
             </a:r>
             <a:r>
-              <a:rPr sz="1600" lang="zh-TW" dirty="0">
+              <a:rPr sz="1400" lang="zh-TW" dirty="0">
                 <a:solidFill>
                   <a:srgbClr val="000000"/>
                 </a:solidFill>
@@ -3928,11 +3928,11 @@
                 <a:spcPts val="0"/>
               </a:spcBef>
               <a:spcAft>
-                <a:spcPts val="267"/>
+                <a:spcPts val="233"/>
               </a:spcAft>
             </a:pPr>
             <a:r>
-              <a:rPr sz="1600" lang="zh-TW" dirty="0">
+              <a:rPr sz="1400" lang="zh-TW" dirty="0">
                 <a:solidFill>
                   <a:srgbClr val="000000"/>
                 </a:solidFill>
@@ -3943,7 +3943,7 @@
               <a:t>ODD 六格，本課的定版：</a:t>
             </a:r>
             <a:r>
-              <a:rPr sz="1600" b="1" lang="zh-TW" dirty="0">
+              <a:rPr sz="1400" b="1" lang="zh-TW" dirty="0">
                 <a:solidFill>
                   <a:srgbClr val="000000"/>
                 </a:solidFill>
@@ -3954,7 +3954,7 @@
               <a:t>道路類型、速度域、交通狀況、天候與光照、地理範圍、人的角色</a:t>
             </a:r>
             <a:r>
-              <a:rPr sz="1600" lang="zh-TW" dirty="0">
+              <a:rPr sz="1400" lang="zh-TW" dirty="0">
                 <a:solidFill>
                   <a:srgbClr val="000000"/>
                 </a:solidFill>
@@ -3972,11 +3972,11 @@
                 <a:spcPts val="0"/>
               </a:spcBef>
               <a:spcAft>
-                <a:spcPts val="267"/>
+                <a:spcPts val="233"/>
               </a:spcAft>
             </a:pPr>
             <a:r>
-              <a:rPr sz="1600" lang="zh-TW" dirty="0">
+              <a:rPr sz="1400" lang="zh-TW" dirty="0">
                 <a:solidFill>
                   <a:srgbClr val="000000"/>
                 </a:solidFill>
@@ -3994,11 +3994,11 @@
                 <a:spcPts val="0"/>
               </a:spcBef>
               <a:spcAft>
-                <a:spcPts val="267"/>
+                <a:spcPts val="233"/>
               </a:spcAft>
             </a:pPr>
             <a:r>
-              <a:rPr sz="1600" lang="zh-TW" dirty="0">
+              <a:rPr sz="1400" lang="zh-TW" dirty="0">
                 <a:solidFill>
                   <a:srgbClr val="000000"/>
                 </a:solidFill>
@@ -4009,7 +4009,7 @@
               <a:t>第一，</a:t>
             </a:r>
             <a:r>
-              <a:rPr sz="1600" b="1" lang="zh-TW" dirty="0">
+              <a:rPr sz="1400" b="1" lang="zh-TW" dirty="0">
                 <a:solidFill>
                   <a:srgbClr val="000000"/>
                 </a:solidFill>
@@ -4020,7 +4020,7 @@
               <a:t>「至少」是下限</a:t>
             </a:r>
             <a:r>
-              <a:rPr sz="1600" lang="zh-TW" dirty="0">
+              <a:rPr sz="1400" lang="zh-TW" dirty="0">
                 <a:solidFill>
                   <a:srgbClr val="000000"/>
                 </a:solidFill>
@@ -4038,11 +4038,11 @@
                 <a:spcPts val="0"/>
               </a:spcBef>
               <a:spcAft>
-                <a:spcPts val="267"/>
+                <a:spcPts val="233"/>
               </a:spcAft>
             </a:pPr>
             <a:r>
-              <a:rPr sz="1600" lang="zh-TW" dirty="0">
+              <a:rPr sz="1400" lang="zh-TW" dirty="0">
                 <a:solidFill>
                   <a:srgbClr val="000000"/>
                 </a:solidFill>
@@ -4053,7 +4053,7 @@
               <a:t>第二，</a:t>
             </a:r>
             <a:r>
-              <a:rPr sz="1600" b="1" lang="zh-TW" dirty="0">
+              <a:rPr sz="1400" b="1" lang="zh-TW" dirty="0">
                 <a:solidFill>
                   <a:srgbClr val="000000"/>
                 </a:solidFill>
@@ -4064,7 +4064,7 @@
               <a:t>單位要看清楚</a:t>
             </a:r>
             <a:r>
-              <a:rPr sz="1600" lang="zh-TW" dirty="0">
+              <a:rPr sz="1400" lang="zh-TW" dirty="0">
                 <a:solidFill>
                   <a:srgbClr val="000000"/>
                 </a:solidFill>
@@ -4072,7 +4072,7 @@
                 <a:ea typeface="Arial Unicode MS"/>
                 <a:cs typeface="Arial Unicode MS"/>
               </a:rPr>
-              <a:t>。mm/h 是雨下得多大，不是積水多深；lx 是照度，亮不亮；能見度不等於感測器的量程。
+              <a:t>。mm/h 是雨下得多大，不是積水多深；能見度不等於感測器的量程。
 </a:t>
             </a:r>
           </a:p>
@@ -4082,11 +4082,11 @@
                 <a:spcPts val="0"/>
               </a:spcBef>
               <a:spcAft>
-                <a:spcPts val="267"/>
+                <a:spcPts val="233"/>
               </a:spcAft>
             </a:pPr>
             <a:r>
-              <a:rPr sz="1600" lang="zh-TW" dirty="0">
+              <a:rPr sz="1400" b="1" lang="zh-TW" dirty="0">
                 <a:solidFill>
                   <a:srgbClr val="000000"/>
                 </a:solidFill>
@@ -4094,10 +4094,10 @@
                 <a:ea typeface="Arial Unicode MS"/>
                 <a:cs typeface="Arial Unicode MS"/>
               </a:rPr>
-              <a:t>第三，</a:t>
-            </a:r>
-            <a:r>
-              <a:rPr sz="1600" b="1" lang="zh-TW" dirty="0">
+              <a:t>lx 是什麼？</a:t>
+            </a:r>
+            <a:r>
+              <a:rPr sz="1400" lang="zh-TW" dirty="0">
                 <a:solidFill>
                   <a:srgbClr val="000000"/>
                 </a:solidFill>
@@ -4105,10 +4105,10 @@
                 <a:ea typeface="Arial Unicode MS"/>
                 <a:cs typeface="Arial Unicode MS"/>
               </a:rPr>
-              <a:t>開慢一點不會讓它變回符合。</a:t>
-            </a:r>
-            <a:r>
-              <a:rPr sz="1600" lang="zh-TW" dirty="0">
+              <a:t>lx 是 lux 的縮寫，中文叫「勒克斯」，是</a:t>
+            </a:r>
+            <a:r>
+              <a:rPr sz="1400" b="1" lang="zh-TW" dirty="0">
                 <a:solidFill>
                   <a:srgbClr val="000000"/>
                 </a:solidFill>
@@ -4116,7 +4116,18 @@
                 <a:ea typeface="Arial Unicode MS"/>
                 <a:cs typeface="Arial Unicode MS"/>
               </a:rPr>
-              <a:t>條件就是條件，不符合就是不符合。
+              <a:t>照度</a:t>
+            </a:r>
+            <a:r>
+              <a:rPr sz="1400" lang="zh-TW" dirty="0">
+                <a:solidFill>
+                  <a:srgbClr val="000000"/>
+                </a:solidFill>
+                <a:latin typeface="Arial Unicode MS"/>
+                <a:ea typeface="Arial Unicode MS"/>
+                <a:cs typeface="Arial Unicode MS"/>
+              </a:rPr>
+              <a:t>的單位，量的是「照在這個地方的光有多少」，數字愈大愈亮。給大家幾個大約的數字：正午的太陽直射大約三萬到十萬 lx，第五週光達規格表上那個「100 klx 陽光」就是這個；陰天白天大約一千；辦公室大約三百到五百；周圍很暗的公共區域照明大約二十到五十；黃昏快結束、天快全黑的時候大約三點四；滿月的晚上只有零點幾。所以「至少 20 lx」大概是「有開燈的暗處」；現場只有 5 lx，就是天快黑、路燈又不夠亮。
 </a:t>
             </a:r>
           </a:p>
@@ -4126,11 +4137,55 @@
                 <a:spcPts val="0"/>
               </a:spcBef>
               <a:spcAft>
-                <a:spcPts val="267"/>
+                <a:spcPts val="233"/>
               </a:spcAft>
             </a:pPr>
             <a:r>
-              <a:rPr sz="1600" lang="zh-TW" dirty="0">
+              <a:rPr sz="1400" lang="zh-TW" dirty="0">
+                <a:solidFill>
+                  <a:srgbClr val="000000"/>
+                </a:solidFill>
+                <a:latin typeface="Arial Unicode MS"/>
+                <a:ea typeface="Arial Unicode MS"/>
+                <a:cs typeface="Arial Unicode MS"/>
+              </a:rPr>
+              <a:t>第三，</a:t>
+            </a:r>
+            <a:r>
+              <a:rPr sz="1400" b="1" lang="zh-TW" dirty="0">
+                <a:solidFill>
+                  <a:srgbClr val="000000"/>
+                </a:solidFill>
+                <a:latin typeface="Arial Unicode MS"/>
+                <a:ea typeface="Arial Unicode MS"/>
+                <a:cs typeface="Arial Unicode MS"/>
+              </a:rPr>
+              <a:t>開慢一點不會讓它變回符合。</a:t>
+            </a:r>
+            <a:r>
+              <a:rPr sz="1400" lang="zh-TW" dirty="0">
+                <a:solidFill>
+                  <a:srgbClr val="000000"/>
+                </a:solidFill>
+                <a:latin typeface="Arial Unicode MS"/>
+                <a:ea typeface="Arial Unicode MS"/>
+                <a:cs typeface="Arial Unicode MS"/>
+              </a:rPr>
+              <a:t>條件就是條件，不符合就是不符合。
+</a:t>
+            </a:r>
+          </a:p>
+          <a:p>
+            <a:pPr algn="l">
+              <a:spcBef>
+                <a:spcPts val="0"/>
+              </a:spcBef>
+              <a:spcAft>
+                <a:spcPts val="233"/>
+              </a:spcAft>
+            </a:pPr>
+            <a:r>
+              <a:rPr sz="1400" lang="zh-TW" dirty="0">
                 <a:solidFill>
                   <a:srgbClr val="000000"/>
                 </a:solidFill>
@@ -17945,7 +18000,7 @@
                           <a:ea typeface="Arial" pitchFamily="34" charset="-122"/>
                           <a:cs typeface="Arial" pitchFamily="34" charset="-120"/>
                         </a:rPr>
-                        <a:t>Không mưa, mặt đường khô; độ rọi ít nhất 20 lx</a:t>
+                        <a:t>Không mưa, mặt đường khô; độ rọi ít nhất 20 lx (lux)</a:t>
                       </a:r>
                       <a:endParaRPr lang="en-US" sz="1180" dirty="0"/>
                     </a:p>
@@ -17962,7 +18017,7 @@
                           <a:ea typeface="微軟正黑體" pitchFamily="34" charset="-122"/>
                           <a:cs typeface="微軟正黑體" pitchFamily="34" charset="-120"/>
                         </a:rPr>
-                        <a:t>無雨、路面乾燥；照度至少 20 lx</a:t>
+                        <a:t>無雨、路面乾燥；照度至少 20 lx（勒克斯）</a:t>
                       </a:r>
                       <a:endParaRPr lang="en-US" sz="1180" dirty="0"/>
                     </a:p>

</xml_diff>

<commit_message>
Week 8 L3 slide 6 + handout: add IMU (week 6) to the what-each-sensor-measures table
Co-Authored-By: Claude Opus 5.5 <noreply@anthropic.com>
</commit_message>
<xml_diff>
--- a/第八週(10-29)/第八週_第3節_簡報.pptx
+++ b/第八週(10-29)/第八週_第3節_簡報.pptx
@@ -4369,7 +4369,7 @@
                 <a:ea typeface="Arial Unicode MS"/>
                 <a:cs typeface="Arial Unicode MS"/>
               </a:rPr>
-              <a:t>看表。相機直接量的是角度和亮度，</a:t>
+              <a:t>看表。前六列是第三週那張表。相機直接量的是角度和亮度，</a:t>
             </a:r>
             <a:r>
               <a:rPr sz="1600" b="1" lang="zh-TW" dirty="0">
@@ -4392,6 +4392,116 @@
                 <a:cs typeface="Arial Unicode MS"/>
               </a:rPr>
               <a:t>，紅綠燈、路牌都靠它；距離是算出來的。光達直接量距離，可是不知道那是什麼。雷達量距離和朝自己的速度。超音波只看近處。衛星定位量的是自己的座標，不知道前面有什麼。熱像量溫度差。
+</a:t>
+            </a:r>
+          </a:p>
+          <a:p>
+            <a:pPr algn="l">
+              <a:spcBef>
+                <a:spcPts val="0"/>
+              </a:spcBef>
+              <a:spcAft>
+                <a:spcPts val="267"/>
+              </a:spcAft>
+            </a:pPr>
+            <a:r>
+              <a:rPr sz="1600" lang="zh-TW" dirty="0">
+                <a:solidFill>
+                  <a:srgbClr val="000000"/>
+                </a:solidFill>
+                <a:latin typeface="Arial Unicode MS"/>
+                <a:ea typeface="Arial Unicode MS"/>
+                <a:cs typeface="Arial Unicode MS"/>
+              </a:rPr>
+              <a:t>最後一列 </a:t>
+            </a:r>
+            <a:r>
+              <a:rPr sz="1600" b="1" lang="zh-TW" dirty="0">
+                <a:solidFill>
+                  <a:srgbClr val="000000"/>
+                </a:solidFill>
+                <a:latin typeface="Arial Unicode MS"/>
+                <a:ea typeface="Arial Unicode MS"/>
+                <a:cs typeface="Arial Unicode MS"/>
+              </a:rPr>
+              <a:t>IMU</a:t>
+            </a:r>
+            <a:r>
+              <a:rPr sz="1600" lang="zh-TW" dirty="0">
+                <a:solidFill>
+                  <a:srgbClr val="000000"/>
+                </a:solidFill>
+                <a:latin typeface="Arial Unicode MS"/>
+                <a:ea typeface="Arial Unicode MS"/>
+                <a:cs typeface="Arial Unicode MS"/>
+              </a:rPr>
+              <a:t> 是第六週加的：它裡面有加速度計和陀螺儀，直接量的是</a:t>
+            </a:r>
+            <a:r>
+              <a:rPr sz="1600" b="1" lang="zh-TW" dirty="0">
+                <a:solidFill>
+                  <a:srgbClr val="000000"/>
+                </a:solidFill>
+                <a:latin typeface="Arial Unicode MS"/>
+                <a:ea typeface="Arial Unicode MS"/>
+                <a:cs typeface="Arial Unicode MS"/>
+              </a:rPr>
+              <a:t>自己</a:t>
+            </a:r>
+            <a:r>
+              <a:rPr sz="1600" lang="zh-TW" dirty="0">
+                <a:solidFill>
+                  <a:srgbClr val="000000"/>
+                </a:solidFill>
+                <a:latin typeface="Arial Unicode MS"/>
+                <a:ea typeface="Arial Unicode MS"/>
+                <a:cs typeface="Arial Unicode MS"/>
+              </a:rPr>
+              <a:t>加速多少、轉得多快，把這些一路加起來，推算自己走到哪裡。它最大的弱點是</a:t>
+            </a:r>
+            <a:r>
+              <a:rPr sz="1600" b="1" lang="zh-TW" dirty="0">
+                <a:solidFill>
+                  <a:srgbClr val="000000"/>
+                </a:solidFill>
+                <a:latin typeface="Arial Unicode MS"/>
+                <a:ea typeface="Arial Unicode MS"/>
+                <a:cs typeface="Arial Unicode MS"/>
+              </a:rPr>
+              <a:t>漂移</a:t>
+            </a:r>
+            <a:r>
+              <a:rPr sz="1600" lang="zh-TW" dirty="0">
+                <a:solidFill>
+                  <a:srgbClr val="000000"/>
+                </a:solidFill>
+                <a:latin typeface="Arial Unicode MS"/>
+                <a:ea typeface="Arial Unicode MS"/>
+                <a:cs typeface="Arial Unicode MS"/>
+              </a:rPr>
+              <a:t>：小小的誤差一直累加，橫向誤差跟時間的平方成正比，所以 IMU 只能補衛星定位短短的空檔，不能單獨用。注意表上有兩種感測器量的是「自己」，不是外面的東西：</a:t>
+            </a:r>
+            <a:r>
+              <a:rPr sz="1600" b="1" lang="zh-TW" dirty="0">
+                <a:solidFill>
+                  <a:srgbClr val="000000"/>
+                </a:solidFill>
+                <a:latin typeface="Arial Unicode MS"/>
+                <a:ea typeface="Arial Unicode MS"/>
+                <a:cs typeface="Arial Unicode MS"/>
+              </a:rPr>
+              <a:t>衛星定位和 IMU</a:t>
+            </a:r>
+            <a:r>
+              <a:rPr sz="1600" lang="zh-TW" dirty="0">
+                <a:solidFill>
+                  <a:srgbClr val="000000"/>
+                </a:solidFill>
+                <a:latin typeface="Arial Unicode MS"/>
+                <a:ea typeface="Arial Unicode MS"/>
+                <a:cs typeface="Arial Unicode MS"/>
+              </a:rPr>
+              <a:t>。
 </a:t>
             </a:r>
           </a:p>
@@ -18565,7 +18675,7 @@
       </p:nvGrpSpPr>
       <p:grpSpPr>
         <a:xfrm>
-          <a:off x="389746" y="0"/>
+          <a:off x="607982" y="0"/>
           <a:ext cx="1" cy="1"/>
           <a:chOff x="0" y="0"/>
           <a:chExt cx="0" cy="0"/>
@@ -18579,8 +18689,8 @@
         </p:nvSpPr>
         <p:spPr>
           <a:xfrm>
-            <a:off x="849794" y="267664"/>
-            <a:ext cx="7444411" cy="769535"/>
+            <a:off x="1044024" y="253697"/>
+            <a:ext cx="7055952" cy="729379"/>
           </a:xfrm>
           <a:prstGeom prst="rect">
             <a:avLst/>
@@ -18599,7 +18709,7 @@
               <a:buNone/>
             </a:pPr>
             <a:r>
-              <a:rPr lang="en-US" sz="2010" b="1" dirty="0">
+              <a:rPr lang="en-US" sz="1910" b="1" dirty="0">
                 <a:solidFill>
                   <a:srgbClr val="0B1F3A"/>
                 </a:solidFill>
@@ -18607,9 +18717,9 @@
                 <a:ea typeface="Arial" pitchFamily="34" charset="-122"/>
                 <a:cs typeface="Arial" pitchFamily="34" charset="-120"/>
               </a:rPr>
-              <a:t>Tuần 3: sáu loại cảm biến đo trực tiếp cái gì</a:t>
-            </a:r>
-            <a:endParaRPr lang="en-US" sz="2010" dirty="0"/>
+              <a:t>Tuần 3 + tuần 6: mỗi cảm biến đo trực tiếp cái gì</a:t>
+            </a:r>
+            <a:endParaRPr lang="en-US" sz="1910" dirty="0"/>
           </a:p>
           <a:p>
             <a:pPr indent="0" marL="0">
@@ -18619,7 +18729,7 @@
               <a:buNone/>
             </a:pPr>
             <a:r>
-              <a:rPr lang="en-US" sz="1230" dirty="0">
+              <a:rPr lang="en-US" sz="1170" dirty="0">
                 <a:solidFill>
                   <a:srgbClr val="5F7183"/>
                 </a:solidFill>
@@ -18627,9 +18737,9 @@
                 <a:ea typeface="微軟正黑體" pitchFamily="34" charset="-122"/>
                 <a:cs typeface="微軟正黑體" pitchFamily="34" charset="-120"/>
               </a:rPr>
-              <a:t>第三週：六種感測器，直接量到什麼</a:t>
-            </a:r>
-            <a:endParaRPr lang="en-US" sz="2010" dirty="0"/>
+              <a:t>第三週＋第六週：每種感測器直接量到什麼</a:t>
+            </a:r>
+            <a:endParaRPr lang="en-US" sz="1910" dirty="0"/>
           </a:p>
         </p:txBody>
       </p:sp>
@@ -18648,20 +18758,20 @@
           </p:nvPr>
         </p:nvGraphicFramePr>
         <p:xfrm>
-          <a:off x="849794" y="1037199"/>
-          <a:ext cx="7444411" cy="836451"/>
+          <a:off x="1044024" y="983076"/>
+          <a:ext cx="7055952" cy="792804"/>
         </p:xfrm>
         <a:graphic>
           <a:graphicData uri="http://schemas.openxmlformats.org/drawingml/2006/table">
             <a:tbl>
               <a:tblPr/>
               <a:tblGrid>
-                <a:gridCol w="1338321"/>
-                <a:gridCol w="2174772"/>
-                <a:gridCol w="1756546"/>
-                <a:gridCol w="2174772"/>
+                <a:gridCol w="1268486"/>
+                <a:gridCol w="2061289"/>
+                <a:gridCol w="1664887"/>
+                <a:gridCol w="2061289"/>
               </a:tblGrid>
-              <a:tr h="301122">
+              <a:tr h="261625">
                 <a:tc>
                   <a:txBody>
                     <a:bodyPr/>
@@ -18671,7 +18781,7 @@
                         <a:buNone/>
                       </a:pPr>
                       <a:r>
-                        <a:rPr lang="en-US" sz="960" b="1" dirty="0">
+                        <a:rPr lang="en-US" sz="870" b="1" dirty="0">
                           <a:solidFill>
                             <a:srgbClr val="FFFFFF"/>
                           </a:solidFill>
@@ -18681,14 +18791,14 @@
                         </a:rPr>
                         <a:t>Cảm biến</a:t>
                       </a:r>
-                      <a:endParaRPr lang="en-US" sz="1100" dirty="0"/>
-                    </a:p>
-                    <a:p>
-                      <a:pPr algn="l" indent="0" marL="0">
-                        <a:buNone/>
-                      </a:pPr>
-                      <a:r>
-                        <a:rPr lang="en-US" sz="820" dirty="0">
+                      <a:endParaRPr lang="en-US" sz="1040" dirty="0"/>
+                    </a:p>
+                    <a:p>
+                      <a:pPr algn="l" indent="0" marL="0">
+                        <a:buNone/>
+                      </a:pPr>
+                      <a:r>
+                        <a:rPr lang="en-US" sz="740" dirty="0">
                           <a:solidFill>
                             <a:srgbClr val="CFE0EC"/>
                           </a:solidFill>
@@ -18698,7 +18808,7 @@
                         </a:rPr>
                         <a:t>感測器</a:t>
                       </a:r>
-                      <a:endParaRPr lang="en-US" sz="1100" dirty="0"/>
+                      <a:endParaRPr lang="en-US" sz="1040" dirty="0"/>
                     </a:p>
                   </a:txBody>
                   <a:tcPr marL="63500" marR="63500" marT="38100" marB="38100" anchor="ctr">
@@ -18752,7 +18862,7 @@
                         <a:buNone/>
                       </a:pPr>
                       <a:r>
-                        <a:rPr lang="en-US" sz="960" b="1" dirty="0">
+                        <a:rPr lang="en-US" sz="870" b="1" dirty="0">
                           <a:solidFill>
                             <a:srgbClr val="FFFFFF"/>
                           </a:solidFill>
@@ -18762,14 +18872,14 @@
                         </a:rPr>
                         <a:t>Đo trực tiếp</a:t>
                       </a:r>
-                      <a:endParaRPr lang="en-US" sz="1100" dirty="0"/>
-                    </a:p>
-                    <a:p>
-                      <a:pPr algn="l" indent="0" marL="0">
-                        <a:buNone/>
-                      </a:pPr>
-                      <a:r>
-                        <a:rPr lang="en-US" sz="820" dirty="0">
+                      <a:endParaRPr lang="en-US" sz="1040" dirty="0"/>
+                    </a:p>
+                    <a:p>
+                      <a:pPr algn="l" indent="0" marL="0">
+                        <a:buNone/>
+                      </a:pPr>
+                      <a:r>
+                        <a:rPr lang="en-US" sz="740" dirty="0">
                           <a:solidFill>
                             <a:srgbClr val="CFE0EC"/>
                           </a:solidFill>
@@ -18779,7 +18889,7 @@
                         </a:rPr>
                         <a:t>直接量到</a:t>
                       </a:r>
-                      <a:endParaRPr lang="en-US" sz="1100" dirty="0"/>
+                      <a:endParaRPr lang="en-US" sz="1040" dirty="0"/>
                     </a:p>
                   </a:txBody>
                   <a:tcPr marL="63500" marR="63500" marT="38100" marB="38100" anchor="ctr">
@@ -18833,7 +18943,7 @@
                         <a:buNone/>
                       </a:pPr>
                       <a:r>
-                        <a:rPr lang="en-US" sz="960" b="1" dirty="0">
+                        <a:rPr lang="en-US" sz="870" b="1" dirty="0">
                           <a:solidFill>
                             <a:srgbClr val="FFFFFF"/>
                           </a:solidFill>
@@ -18843,14 +18953,14 @@
                         </a:rPr>
                         <a:t>Tầm (trời nắng, giá trị lớp học)</a:t>
                       </a:r>
-                      <a:endParaRPr lang="en-US" sz="1100" dirty="0"/>
-                    </a:p>
-                    <a:p>
-                      <a:pPr algn="l" indent="0" marL="0">
-                        <a:buNone/>
-                      </a:pPr>
-                      <a:r>
-                        <a:rPr lang="en-US" sz="820" dirty="0">
+                      <a:endParaRPr lang="en-US" sz="1040" dirty="0"/>
+                    </a:p>
+                    <a:p>
+                      <a:pPr algn="l" indent="0" marL="0">
+                        <a:buNone/>
+                      </a:pPr>
+                      <a:r>
+                        <a:rPr lang="en-US" sz="740" dirty="0">
                           <a:solidFill>
                             <a:srgbClr val="CFE0EC"/>
                           </a:solidFill>
@@ -18860,7 +18970,7 @@
                         </a:rPr>
                         <a:t>有效距離（晴天，課堂設定）</a:t>
                       </a:r>
-                      <a:endParaRPr lang="en-US" sz="1100" dirty="0"/>
+                      <a:endParaRPr lang="en-US" sz="1040" dirty="0"/>
                     </a:p>
                   </a:txBody>
                   <a:tcPr marL="63500" marR="63500" marT="38100" marB="38100" anchor="ctr">
@@ -18914,7 +19024,7 @@
                         <a:buNone/>
                       </a:pPr>
                       <a:r>
-                        <a:rPr lang="en-US" sz="960" b="1" dirty="0">
+                        <a:rPr lang="en-US" sz="870" b="1" dirty="0">
                           <a:solidFill>
                             <a:srgbClr val="FFFFFF"/>
                           </a:solidFill>
@@ -18924,14 +19034,14 @@
                         </a:rPr>
                         <a:t>Điểm yếu</a:t>
                       </a:r>
-                      <a:endParaRPr lang="en-US" sz="1100" dirty="0"/>
-                    </a:p>
-                    <a:p>
-                      <a:pPr algn="l" indent="0" marL="0">
-                        <a:buNone/>
-                      </a:pPr>
-                      <a:r>
-                        <a:rPr lang="en-US" sz="820" dirty="0">
+                      <a:endParaRPr lang="en-US" sz="1040" dirty="0"/>
+                    </a:p>
+                    <a:p>
+                      <a:pPr algn="l" indent="0" marL="0">
+                        <a:buNone/>
+                      </a:pPr>
+                      <a:r>
+                        <a:rPr lang="en-US" sz="740" dirty="0">
                           <a:solidFill>
                             <a:srgbClr val="CFE0EC"/>
                           </a:solidFill>
@@ -18941,7 +19051,7 @@
                         </a:rPr>
                         <a:t>弱點</a:t>
                       </a:r>
-                      <a:endParaRPr lang="en-US" sz="1100" dirty="0"/>
+                      <a:endParaRPr lang="en-US" sz="1040" dirty="0"/>
                     </a:p>
                   </a:txBody>
                   <a:tcPr marL="63500" marR="63500" marT="38100" marB="38100" anchor="ctr">
@@ -18987,7 +19097,7 @@
                   </a:tcPr>
                 </a:tc>
               </a:tr>
-              <a:tr h="301122">
+              <a:tr h="261625">
                 <a:tc>
                   <a:txBody>
                     <a:bodyPr/>
@@ -18997,7 +19107,7 @@
                         <a:buNone/>
                       </a:pPr>
                       <a:r>
-                        <a:rPr lang="en-US" sz="960" b="1" dirty="0">
+                        <a:rPr lang="en-US" sz="870" b="1" dirty="0">
                           <a:solidFill>
                             <a:srgbClr val="0B1F3A"/>
                           </a:solidFill>
@@ -19007,14 +19117,14 @@
                         </a:rPr>
                         <a:t>Camera</a:t>
                       </a:r>
-                      <a:endParaRPr lang="en-US" sz="1100" dirty="0"/>
-                    </a:p>
-                    <a:p>
-                      <a:pPr algn="l" indent="0" marL="0">
-                        <a:buNone/>
-                      </a:pPr>
-                      <a:r>
-                        <a:rPr lang="en-US" sz="820" dirty="0">
+                      <a:endParaRPr lang="en-US" sz="1040" dirty="0"/>
+                    </a:p>
+                    <a:p>
+                      <a:pPr algn="l" indent="0" marL="0">
+                        <a:buNone/>
+                      </a:pPr>
+                      <a:r>
+                        <a:rPr lang="en-US" sz="740" dirty="0">
                           <a:solidFill>
                             <a:srgbClr val="5F7183"/>
                           </a:solidFill>
@@ -19024,7 +19134,7 @@
                         </a:rPr>
                         <a:t>相機</a:t>
                       </a:r>
-                      <a:endParaRPr lang="en-US" sz="1100" dirty="0"/>
+                      <a:endParaRPr lang="en-US" sz="1040" dirty="0"/>
                     </a:p>
                   </a:txBody>
                   <a:tcPr marL="63500" marR="63500" marT="38100" marB="38100" anchor="ctr">
@@ -19075,7 +19185,7 @@
                         <a:buNone/>
                       </a:pPr>
                       <a:r>
-                        <a:rPr lang="en-US" sz="960" dirty="0">
+                        <a:rPr lang="en-US" sz="870" dirty="0">
                           <a:solidFill>
                             <a:srgbClr val="1A2733"/>
                           </a:solidFill>
@@ -19085,14 +19195,14 @@
                         </a:rPr>
                         <a:t>Góc, độ sáng, màu</a:t>
                       </a:r>
-                      <a:endParaRPr lang="en-US" sz="1100" dirty="0"/>
-                    </a:p>
-                    <a:p>
-                      <a:pPr algn="l" indent="0" marL="0">
-                        <a:buNone/>
-                      </a:pPr>
-                      <a:r>
-                        <a:rPr lang="en-US" sz="820" dirty="0">
+                      <a:endParaRPr lang="en-US" sz="1040" dirty="0"/>
+                    </a:p>
+                    <a:p>
+                      <a:pPr algn="l" indent="0" marL="0">
+                        <a:buNone/>
+                      </a:pPr>
+                      <a:r>
+                        <a:rPr lang="en-US" sz="740" dirty="0">
                           <a:solidFill>
                             <a:srgbClr val="5F7183"/>
                           </a:solidFill>
@@ -19102,7 +19212,7 @@
                         </a:rPr>
                         <a:t>角度、亮度、顏色</a:t>
                       </a:r>
-                      <a:endParaRPr lang="en-US" sz="1100" dirty="0"/>
+                      <a:endParaRPr lang="en-US" sz="1040" dirty="0"/>
                     </a:p>
                   </a:txBody>
                   <a:tcPr marL="63500" marR="63500" marT="38100" marB="38100" anchor="ctr">
@@ -19153,7 +19263,7 @@
                         <a:buNone/>
                       </a:pPr>
                       <a:r>
-                        <a:rPr lang="en-US" sz="960" dirty="0">
+                        <a:rPr lang="en-US" sz="870" dirty="0">
                           <a:solidFill>
                             <a:srgbClr val="1A2733"/>
                           </a:solidFill>
@@ -19163,7 +19273,7 @@
                         </a:rPr>
                         <a:t>80 m</a:t>
                       </a:r>
-                      <a:endParaRPr lang="en-US" sz="1100" dirty="0"/>
+                      <a:endParaRPr lang="en-US" sz="1040" dirty="0"/>
                     </a:p>
                   </a:txBody>
                   <a:tcPr marL="63500" marR="63500" marT="38100" marB="38100" anchor="ctr">
@@ -19214,7 +19324,7 @@
                         <a:buNone/>
                       </a:pPr>
                       <a:r>
-                        <a:rPr lang="en-US" sz="960" dirty="0">
+                        <a:rPr lang="en-US" sz="870" dirty="0">
                           <a:solidFill>
                             <a:srgbClr val="1A2733"/>
                           </a:solidFill>
@@ -19224,14 +19334,14 @@
                         </a:rPr>
                         <a:t>Khoảng cách là đoán; sợ tối, mưa</a:t>
                       </a:r>
-                      <a:endParaRPr lang="en-US" sz="1100" dirty="0"/>
-                    </a:p>
-                    <a:p>
-                      <a:pPr algn="l" indent="0" marL="0">
-                        <a:buNone/>
-                      </a:pPr>
-                      <a:r>
-                        <a:rPr lang="en-US" sz="820" dirty="0">
+                      <a:endParaRPr lang="en-US" sz="1040" dirty="0"/>
+                    </a:p>
+                    <a:p>
+                      <a:pPr algn="l" indent="0" marL="0">
+                        <a:buNone/>
+                      </a:pPr>
+                      <a:r>
+                        <a:rPr lang="en-US" sz="740" dirty="0">
                           <a:solidFill>
                             <a:srgbClr val="5F7183"/>
                           </a:solidFill>
@@ -19241,7 +19351,7 @@
                         </a:rPr>
                         <a:t>距離是算的；怕暗、怕雨</a:t>
                       </a:r>
-                      <a:endParaRPr lang="en-US" sz="1100" dirty="0"/>
+                      <a:endParaRPr lang="en-US" sz="1040" dirty="0"/>
                     </a:p>
                   </a:txBody>
                   <a:tcPr marL="63500" marR="63500" marT="38100" marB="38100" anchor="ctr">
@@ -19284,7 +19394,7 @@
                   </a:tcPr>
                 </a:tc>
               </a:tr>
-              <a:tr h="301122">
+              <a:tr h="261625">
                 <a:tc>
                   <a:txBody>
                     <a:bodyPr/>
@@ -19294,7 +19404,7 @@
                         <a:buNone/>
                       </a:pPr>
                       <a:r>
-                        <a:rPr lang="en-US" sz="960" b="1" dirty="0">
+                        <a:rPr lang="en-US" sz="870" b="1" dirty="0">
                           <a:solidFill>
                             <a:srgbClr val="0B1F3A"/>
                           </a:solidFill>
@@ -19304,14 +19414,14 @@
                         </a:rPr>
                         <a:t>Lidar</a:t>
                       </a:r>
-                      <a:endParaRPr lang="en-US" sz="1100" dirty="0"/>
-                    </a:p>
-                    <a:p>
-                      <a:pPr algn="l" indent="0" marL="0">
-                        <a:buNone/>
-                      </a:pPr>
-                      <a:r>
-                        <a:rPr lang="en-US" sz="820" dirty="0">
+                      <a:endParaRPr lang="en-US" sz="1040" dirty="0"/>
+                    </a:p>
+                    <a:p>
+                      <a:pPr algn="l" indent="0" marL="0">
+                        <a:buNone/>
+                      </a:pPr>
+                      <a:r>
+                        <a:rPr lang="en-US" sz="740" dirty="0">
                           <a:solidFill>
                             <a:srgbClr val="5F7183"/>
                           </a:solidFill>
@@ -19321,7 +19431,7 @@
                         </a:rPr>
                         <a:t>光達</a:t>
                       </a:r>
-                      <a:endParaRPr lang="en-US" sz="1100" dirty="0"/>
+                      <a:endParaRPr lang="en-US" sz="1040" dirty="0"/>
                     </a:p>
                   </a:txBody>
                   <a:tcPr marL="63500" marR="63500" marT="38100" marB="38100" anchor="ctr">
@@ -19372,7 +19482,7 @@
                         <a:buNone/>
                       </a:pPr>
                       <a:r>
-                        <a:rPr lang="en-US" sz="960" dirty="0">
+                        <a:rPr lang="en-US" sz="870" dirty="0">
                           <a:solidFill>
                             <a:srgbClr val="1A2733"/>
                           </a:solidFill>
@@ -19382,14 +19492,14 @@
                         </a:rPr>
                         <a:t>Khoảng cách (thời gian bay)</a:t>
                       </a:r>
-                      <a:endParaRPr lang="en-US" sz="1100" dirty="0"/>
-                    </a:p>
-                    <a:p>
-                      <a:pPr algn="l" indent="0" marL="0">
-                        <a:buNone/>
-                      </a:pPr>
-                      <a:r>
-                        <a:rPr lang="en-US" sz="820" dirty="0">
+                      <a:endParaRPr lang="en-US" sz="1040" dirty="0"/>
+                    </a:p>
+                    <a:p>
+                      <a:pPr algn="l" indent="0" marL="0">
+                        <a:buNone/>
+                      </a:pPr>
+                      <a:r>
+                        <a:rPr lang="en-US" sz="740" dirty="0">
                           <a:solidFill>
                             <a:srgbClr val="5F7183"/>
                           </a:solidFill>
@@ -19399,7 +19509,7 @@
                         </a:rPr>
                         <a:t>距離（飛行時間）</a:t>
                       </a:r>
-                      <a:endParaRPr lang="en-US" sz="1100" dirty="0"/>
+                      <a:endParaRPr lang="en-US" sz="1040" dirty="0"/>
                     </a:p>
                   </a:txBody>
                   <a:tcPr marL="63500" marR="63500" marT="38100" marB="38100" anchor="ctr">
@@ -19450,7 +19560,7 @@
                         <a:buNone/>
                       </a:pPr>
                       <a:r>
-                        <a:rPr lang="en-US" sz="960" dirty="0">
+                        <a:rPr lang="en-US" sz="870" dirty="0">
                           <a:solidFill>
                             <a:srgbClr val="1A2733"/>
                           </a:solidFill>
@@ -19460,7 +19570,7 @@
                         </a:rPr>
                         <a:t>100 m</a:t>
                       </a:r>
-                      <a:endParaRPr lang="en-US" sz="1100" dirty="0"/>
+                      <a:endParaRPr lang="en-US" sz="1040" dirty="0"/>
                     </a:p>
                   </a:txBody>
                   <a:tcPr marL="63500" marR="63500" marT="38100" marB="38100" anchor="ctr">
@@ -19511,7 +19621,7 @@
                         <a:buNone/>
                       </a:pPr>
                       <a:r>
-                        <a:rPr lang="en-US" sz="960" dirty="0">
+                        <a:rPr lang="en-US" sz="870" dirty="0">
                           <a:solidFill>
                             <a:srgbClr val="1A2733"/>
                           </a:solidFill>
@@ -19521,14 +19631,14 @@
                         </a:rPr>
                         <a:t>Xa thì thưa; không biết «là gì»</a:t>
                       </a:r>
-                      <a:endParaRPr lang="en-US" sz="1100" dirty="0"/>
-                    </a:p>
-                    <a:p>
-                      <a:pPr algn="l" indent="0" marL="0">
-                        <a:buNone/>
-                      </a:pPr>
-                      <a:r>
-                        <a:rPr lang="en-US" sz="820" dirty="0">
+                      <a:endParaRPr lang="en-US" sz="1040" dirty="0"/>
+                    </a:p>
+                    <a:p>
+                      <a:pPr algn="l" indent="0" marL="0">
+                        <a:buNone/>
+                      </a:pPr>
+                      <a:r>
+                        <a:rPr lang="en-US" sz="740" dirty="0">
                           <a:solidFill>
                             <a:srgbClr val="5F7183"/>
                           </a:solidFill>
@@ -19538,7 +19648,7 @@
                         </a:rPr>
                         <a:t>一遠就稀；不知道是什麼</a:t>
                       </a:r>
-                      <a:endParaRPr lang="en-US" sz="1100" dirty="0"/>
+                      <a:endParaRPr lang="en-US" sz="1040" dirty="0"/>
                     </a:p>
                   </a:txBody>
                   <a:tcPr marL="63500" marR="63500" marT="38100" marB="38100" anchor="ctr">
@@ -19581,7 +19691,7 @@
                   </a:tcPr>
                 </a:tc>
               </a:tr>
-              <a:tr h="301122">
+              <a:tr h="261625">
                 <a:tc>
                   <a:txBody>
                     <a:bodyPr/>
@@ -19591,7 +19701,7 @@
                         <a:buNone/>
                       </a:pPr>
                       <a:r>
-                        <a:rPr lang="en-US" sz="960" b="1" dirty="0">
+                        <a:rPr lang="en-US" sz="870" b="1" dirty="0">
                           <a:solidFill>
                             <a:srgbClr val="0B1F3A"/>
                           </a:solidFill>
@@ -19601,14 +19711,14 @@
                         </a:rPr>
                         <a:t>Radar</a:t>
                       </a:r>
-                      <a:endParaRPr lang="en-US" sz="1100" dirty="0"/>
-                    </a:p>
-                    <a:p>
-                      <a:pPr algn="l" indent="0" marL="0">
-                        <a:buNone/>
-                      </a:pPr>
-                      <a:r>
-                        <a:rPr lang="en-US" sz="820" dirty="0">
+                      <a:endParaRPr lang="en-US" sz="1040" dirty="0"/>
+                    </a:p>
+                    <a:p>
+                      <a:pPr algn="l" indent="0" marL="0">
+                        <a:buNone/>
+                      </a:pPr>
+                      <a:r>
+                        <a:rPr lang="en-US" sz="740" dirty="0">
                           <a:solidFill>
                             <a:srgbClr val="5F7183"/>
                           </a:solidFill>
@@ -19618,7 +19728,7 @@
                         </a:rPr>
                         <a:t>雷達</a:t>
                       </a:r>
-                      <a:endParaRPr lang="en-US" sz="1100" dirty="0"/>
+                      <a:endParaRPr lang="en-US" sz="1040" dirty="0"/>
                     </a:p>
                   </a:txBody>
                   <a:tcPr marL="63500" marR="63500" marT="38100" marB="38100" anchor="ctr">
@@ -19669,7 +19779,7 @@
                         <a:buNone/>
                       </a:pPr>
                       <a:r>
-                        <a:rPr lang="en-US" sz="960" dirty="0">
+                        <a:rPr lang="en-US" sz="870" dirty="0">
                           <a:solidFill>
                             <a:srgbClr val="1A2733"/>
                           </a:solidFill>
@@ -19679,14 +19789,14 @@
                         </a:rPr>
                         <a:t>Khoảng cách + tốc độ hướng tâm</a:t>
                       </a:r>
-                      <a:endParaRPr lang="en-US" sz="1100" dirty="0"/>
-                    </a:p>
-                    <a:p>
-                      <a:pPr algn="l" indent="0" marL="0">
-                        <a:buNone/>
-                      </a:pPr>
-                      <a:r>
-                        <a:rPr lang="en-US" sz="820" dirty="0">
+                      <a:endParaRPr lang="en-US" sz="1040" dirty="0"/>
+                    </a:p>
+                    <a:p>
+                      <a:pPr algn="l" indent="0" marL="0">
+                        <a:buNone/>
+                      </a:pPr>
+                      <a:r>
+                        <a:rPr lang="en-US" sz="740" dirty="0">
                           <a:solidFill>
                             <a:srgbClr val="5F7183"/>
                           </a:solidFill>
@@ -19696,7 +19806,7 @@
                         </a:rPr>
                         <a:t>距離＋朝自己的速度</a:t>
                       </a:r>
-                      <a:endParaRPr lang="en-US" sz="1100" dirty="0"/>
+                      <a:endParaRPr lang="en-US" sz="1040" dirty="0"/>
                     </a:p>
                   </a:txBody>
                   <a:tcPr marL="63500" marR="63500" marT="38100" marB="38100" anchor="ctr">
@@ -19747,7 +19857,7 @@
                         <a:buNone/>
                       </a:pPr>
                       <a:r>
-                        <a:rPr lang="en-US" sz="960" dirty="0">
+                        <a:rPr lang="en-US" sz="870" dirty="0">
                           <a:solidFill>
                             <a:srgbClr val="1A2733"/>
                           </a:solidFill>
@@ -19757,7 +19867,7 @@
                         </a:rPr>
                         <a:t>250 m</a:t>
                       </a:r>
-                      <a:endParaRPr lang="en-US" sz="1100" dirty="0"/>
+                      <a:endParaRPr lang="en-US" sz="1040" dirty="0"/>
                     </a:p>
                   </a:txBody>
                   <a:tcPr marL="63500" marR="63500" marT="38100" marB="38100" anchor="ctr">
@@ -19808,7 +19918,7 @@
                         <a:buNone/>
                       </a:pPr>
                       <a:r>
-                        <a:rPr lang="en-US" sz="960" dirty="0">
+                        <a:rPr lang="en-US" sz="870" dirty="0">
                           <a:solidFill>
                             <a:srgbClr val="1A2733"/>
                           </a:solidFill>
@@ -19818,14 +19928,14 @@
                         </a:rPr>
                         <a:t>Góc thô; ít bắt người, xe máy</a:t>
                       </a:r>
-                      <a:endParaRPr lang="en-US" sz="1100" dirty="0"/>
-                    </a:p>
-                    <a:p>
-                      <a:pPr algn="l" indent="0" marL="0">
-                        <a:buNone/>
-                      </a:pPr>
-                      <a:r>
-                        <a:rPr lang="en-US" sz="820" dirty="0">
+                      <a:endParaRPr lang="en-US" sz="1040" dirty="0"/>
+                    </a:p>
+                    <a:p>
+                      <a:pPr algn="l" indent="0" marL="0">
+                        <a:buNone/>
+                      </a:pPr>
+                      <a:r>
+                        <a:rPr lang="en-US" sz="740" dirty="0">
                           <a:solidFill>
                             <a:srgbClr val="5F7183"/>
                           </a:solidFill>
@@ -19835,7 +19945,7 @@
                         </a:rPr>
                         <a:t>角度粗；抓不太到人、機車</a:t>
                       </a:r>
-                      <a:endParaRPr lang="en-US" sz="1100" dirty="0"/>
+                      <a:endParaRPr lang="en-US" sz="1040" dirty="0"/>
                     </a:p>
                   </a:txBody>
                   <a:tcPr marL="63500" marR="63500" marT="38100" marB="38100" anchor="ctr">
@@ -19878,7 +19988,7 @@
                   </a:tcPr>
                 </a:tc>
               </a:tr>
-              <a:tr h="301122">
+              <a:tr h="261625">
                 <a:tc>
                   <a:txBody>
                     <a:bodyPr/>
@@ -19888,7 +19998,7 @@
                         <a:buNone/>
                       </a:pPr>
                       <a:r>
-                        <a:rPr lang="en-US" sz="960" b="1" dirty="0">
+                        <a:rPr lang="en-US" sz="870" b="1" dirty="0">
                           <a:solidFill>
                             <a:srgbClr val="0B1F3A"/>
                           </a:solidFill>
@@ -19898,14 +20008,14 @@
                         </a:rPr>
                         <a:t>Siêu âm</a:t>
                       </a:r>
-                      <a:endParaRPr lang="en-US" sz="1100" dirty="0"/>
-                    </a:p>
-                    <a:p>
-                      <a:pPr algn="l" indent="0" marL="0">
-                        <a:buNone/>
-                      </a:pPr>
-                      <a:r>
-                        <a:rPr lang="en-US" sz="820" dirty="0">
+                      <a:endParaRPr lang="en-US" sz="1040" dirty="0"/>
+                    </a:p>
+                    <a:p>
+                      <a:pPr algn="l" indent="0" marL="0">
+                        <a:buNone/>
+                      </a:pPr>
+                      <a:r>
+                        <a:rPr lang="en-US" sz="740" dirty="0">
                           <a:solidFill>
                             <a:srgbClr val="5F7183"/>
                           </a:solidFill>
@@ -19915,7 +20025,7 @@
                         </a:rPr>
                         <a:t>超音波</a:t>
                       </a:r>
-                      <a:endParaRPr lang="en-US" sz="1100" dirty="0"/>
+                      <a:endParaRPr lang="en-US" sz="1040" dirty="0"/>
                     </a:p>
                   </a:txBody>
                   <a:tcPr marL="63500" marR="63500" marT="38100" marB="38100" anchor="ctr">
@@ -19966,7 +20076,7 @@
                         <a:buNone/>
                       </a:pPr>
                       <a:r>
-                        <a:rPr lang="en-US" sz="960" dirty="0">
+                        <a:rPr lang="en-US" sz="870" dirty="0">
                           <a:solidFill>
                             <a:srgbClr val="1A2733"/>
                           </a:solidFill>
@@ -19976,14 +20086,14 @@
                         </a:rPr>
                         <a:t>Khoảng cách</a:t>
                       </a:r>
-                      <a:endParaRPr lang="en-US" sz="1100" dirty="0"/>
-                    </a:p>
-                    <a:p>
-                      <a:pPr algn="l" indent="0" marL="0">
-                        <a:buNone/>
-                      </a:pPr>
-                      <a:r>
-                        <a:rPr lang="en-US" sz="820" dirty="0">
+                      <a:endParaRPr lang="en-US" sz="1040" dirty="0"/>
+                    </a:p>
+                    <a:p>
+                      <a:pPr algn="l" indent="0" marL="0">
+                        <a:buNone/>
+                      </a:pPr>
+                      <a:r>
+                        <a:rPr lang="en-US" sz="740" dirty="0">
                           <a:solidFill>
                             <a:srgbClr val="5F7183"/>
                           </a:solidFill>
@@ -19993,7 +20103,7 @@
                         </a:rPr>
                         <a:t>距離</a:t>
                       </a:r>
-                      <a:endParaRPr lang="en-US" sz="1100" dirty="0"/>
+                      <a:endParaRPr lang="en-US" sz="1040" dirty="0"/>
                     </a:p>
                   </a:txBody>
                   <a:tcPr marL="63500" marR="63500" marT="38100" marB="38100" anchor="ctr">
@@ -20044,7 +20154,7 @@
                         <a:buNone/>
                       </a:pPr>
                       <a:r>
-                        <a:rPr lang="en-US" sz="960" dirty="0">
+                        <a:rPr lang="en-US" sz="870" dirty="0">
                           <a:solidFill>
                             <a:srgbClr val="1A2733"/>
                           </a:solidFill>
@@ -20054,7 +20164,7 @@
                         </a:rPr>
                         <a:t>4.5 m</a:t>
                       </a:r>
-                      <a:endParaRPr lang="en-US" sz="1100" dirty="0"/>
+                      <a:endParaRPr lang="en-US" sz="1040" dirty="0"/>
                     </a:p>
                   </a:txBody>
                   <a:tcPr marL="63500" marR="63500" marT="38100" marB="38100" anchor="ctr">
@@ -20105,7 +20215,7 @@
                         <a:buNone/>
                       </a:pPr>
                       <a:r>
-                        <a:rPr lang="en-US" sz="960" dirty="0">
+                        <a:rPr lang="en-US" sz="870" dirty="0">
                           <a:solidFill>
                             <a:srgbClr val="1A2733"/>
                           </a:solidFill>
@@ -20115,14 +20225,14 @@
                         </a:rPr>
                         <a:t>Chỉ gần</a:t>
                       </a:r>
-                      <a:endParaRPr lang="en-US" sz="1100" dirty="0"/>
-                    </a:p>
-                    <a:p>
-                      <a:pPr algn="l" indent="0" marL="0">
-                        <a:buNone/>
-                      </a:pPr>
-                      <a:r>
-                        <a:rPr lang="en-US" sz="820" dirty="0">
+                      <a:endParaRPr lang="en-US" sz="1040" dirty="0"/>
+                    </a:p>
+                    <a:p>
+                      <a:pPr algn="l" indent="0" marL="0">
+                        <a:buNone/>
+                      </a:pPr>
+                      <a:r>
+                        <a:rPr lang="en-US" sz="740" dirty="0">
                           <a:solidFill>
                             <a:srgbClr val="5F7183"/>
                           </a:solidFill>
@@ -20132,7 +20242,7 @@
                         </a:rPr>
                         <a:t>只看近處</a:t>
                       </a:r>
-                      <a:endParaRPr lang="en-US" sz="1100" dirty="0"/>
+                      <a:endParaRPr lang="en-US" sz="1040" dirty="0"/>
                     </a:p>
                   </a:txBody>
                   <a:tcPr marL="63500" marR="63500" marT="38100" marB="38100" anchor="ctr">
@@ -20175,7 +20285,7 @@
                   </a:tcPr>
                 </a:tc>
               </a:tr>
-              <a:tr h="301122">
+              <a:tr h="261625">
                 <a:tc>
                   <a:txBody>
                     <a:bodyPr/>
@@ -20185,7 +20295,7 @@
                         <a:buNone/>
                       </a:pPr>
                       <a:r>
-                        <a:rPr lang="en-US" sz="960" b="1" dirty="0">
+                        <a:rPr lang="en-US" sz="870" b="1" dirty="0">
                           <a:solidFill>
                             <a:srgbClr val="0B1F3A"/>
                           </a:solidFill>
@@ -20195,14 +20305,14 @@
                         </a:rPr>
                         <a:t>GNSS</a:t>
                       </a:r>
-                      <a:endParaRPr lang="en-US" sz="1100" dirty="0"/>
-                    </a:p>
-                    <a:p>
-                      <a:pPr algn="l" indent="0" marL="0">
-                        <a:buNone/>
-                      </a:pPr>
-                      <a:r>
-                        <a:rPr lang="en-US" sz="820" dirty="0">
+                      <a:endParaRPr lang="en-US" sz="1040" dirty="0"/>
+                    </a:p>
+                    <a:p>
+                      <a:pPr algn="l" indent="0" marL="0">
+                        <a:buNone/>
+                      </a:pPr>
+                      <a:r>
+                        <a:rPr lang="en-US" sz="740" dirty="0">
                           <a:solidFill>
                             <a:srgbClr val="5F7183"/>
                           </a:solidFill>
@@ -20212,7 +20322,7 @@
                         </a:rPr>
                         <a:t>衛星定位</a:t>
                       </a:r>
-                      <a:endParaRPr lang="en-US" sz="1100" dirty="0"/>
+                      <a:endParaRPr lang="en-US" sz="1040" dirty="0"/>
                     </a:p>
                   </a:txBody>
                   <a:tcPr marL="63500" marR="63500" marT="38100" marB="38100" anchor="ctr">
@@ -20263,7 +20373,7 @@
                         <a:buNone/>
                       </a:pPr>
                       <a:r>
-                        <a:rPr lang="en-US" sz="960" dirty="0">
+                        <a:rPr lang="en-US" sz="870" dirty="0">
                           <a:solidFill>
                             <a:srgbClr val="1A2733"/>
                           </a:solidFill>
@@ -20273,14 +20383,14 @@
                         </a:rPr>
                         <a:t>Toạ độ của chính mình</a:t>
                       </a:r>
-                      <a:endParaRPr lang="en-US" sz="1100" dirty="0"/>
-                    </a:p>
-                    <a:p>
-                      <a:pPr algn="l" indent="0" marL="0">
-                        <a:buNone/>
-                      </a:pPr>
-                      <a:r>
-                        <a:rPr lang="en-US" sz="820" dirty="0">
+                      <a:endParaRPr lang="en-US" sz="1040" dirty="0"/>
+                    </a:p>
+                    <a:p>
+                      <a:pPr algn="l" indent="0" marL="0">
+                        <a:buNone/>
+                      </a:pPr>
+                      <a:r>
+                        <a:rPr lang="en-US" sz="740" dirty="0">
                           <a:solidFill>
                             <a:srgbClr val="5F7183"/>
                           </a:solidFill>
@@ -20290,7 +20400,7 @@
                         </a:rPr>
                         <a:t>自己的座標</a:t>
                       </a:r>
-                      <a:endParaRPr lang="en-US" sz="1100" dirty="0"/>
+                      <a:endParaRPr lang="en-US" sz="1040" dirty="0"/>
                     </a:p>
                   </a:txBody>
                   <a:tcPr marL="63500" marR="63500" marT="38100" marB="38100" anchor="ctr">
@@ -20341,7 +20451,7 @@
                         <a:buNone/>
                       </a:pPr>
                       <a:r>
-                        <a:rPr lang="en-US" sz="960" dirty="0">
+                        <a:rPr lang="en-US" sz="870" dirty="0">
                           <a:solidFill>
                             <a:srgbClr val="1A2733"/>
                           </a:solidFill>
@@ -20351,7 +20461,7 @@
                         </a:rPr>
                         <a:t>±2.5 m</a:t>
                       </a:r>
-                      <a:endParaRPr lang="en-US" sz="1100" dirty="0"/>
+                      <a:endParaRPr lang="en-US" sz="1040" dirty="0"/>
                     </a:p>
                   </a:txBody>
                   <a:tcPr marL="63500" marR="63500" marT="38100" marB="38100" anchor="ctr">
@@ -20402,7 +20512,7 @@
                         <a:buNone/>
                       </a:pPr>
                       <a:r>
-                        <a:rPr lang="en-US" sz="960" dirty="0">
+                        <a:rPr lang="en-US" sz="870" dirty="0">
                           <a:solidFill>
                             <a:srgbClr val="1A2733"/>
                           </a:solidFill>
@@ -20412,14 +20522,14 @@
                         </a:rPr>
                         <a:t>Không biết phía trước có gì; hầm thì mất</a:t>
                       </a:r>
-                      <a:endParaRPr lang="en-US" sz="1100" dirty="0"/>
-                    </a:p>
-                    <a:p>
-                      <a:pPr algn="l" indent="0" marL="0">
-                        <a:buNone/>
-                      </a:pPr>
-                      <a:r>
-                        <a:rPr lang="en-US" sz="820" dirty="0">
+                      <a:endParaRPr lang="en-US" sz="1040" dirty="0"/>
+                    </a:p>
+                    <a:p>
+                      <a:pPr algn="l" indent="0" marL="0">
+                        <a:buNone/>
+                      </a:pPr>
+                      <a:r>
+                        <a:rPr lang="en-US" sz="740" dirty="0">
                           <a:solidFill>
                             <a:srgbClr val="5F7183"/>
                           </a:solidFill>
@@ -20429,7 +20539,7 @@
                         </a:rPr>
                         <a:t>不知道前面有什麼；隧道沒訊號</a:t>
                       </a:r>
-                      <a:endParaRPr lang="en-US" sz="1100" dirty="0"/>
+                      <a:endParaRPr lang="en-US" sz="1040" dirty="0"/>
                     </a:p>
                   </a:txBody>
                   <a:tcPr marL="63500" marR="63500" marT="38100" marB="38100" anchor="ctr">
@@ -20472,7 +20582,7 @@
                   </a:tcPr>
                 </a:tc>
               </a:tr>
-              <a:tr h="301122">
+              <a:tr h="261625">
                 <a:tc>
                   <a:txBody>
                     <a:bodyPr/>
@@ -20482,7 +20592,7 @@
                         <a:buNone/>
                       </a:pPr>
                       <a:r>
-                        <a:rPr lang="en-US" sz="960" b="1" dirty="0">
+                        <a:rPr lang="en-US" sz="870" b="1" dirty="0">
                           <a:solidFill>
                             <a:srgbClr val="0B1F3A"/>
                           </a:solidFill>
@@ -20492,14 +20602,14 @@
                         </a:rPr>
                         <a:t>Camera nhiệt</a:t>
                       </a:r>
-                      <a:endParaRPr lang="en-US" sz="1100" dirty="0"/>
-                    </a:p>
-                    <a:p>
-                      <a:pPr algn="l" indent="0" marL="0">
-                        <a:buNone/>
-                      </a:pPr>
-                      <a:r>
-                        <a:rPr lang="en-US" sz="820" dirty="0">
+                      <a:endParaRPr lang="en-US" sz="1040" dirty="0"/>
+                    </a:p>
+                    <a:p>
+                      <a:pPr algn="l" indent="0" marL="0">
+                        <a:buNone/>
+                      </a:pPr>
+                      <a:r>
+                        <a:rPr lang="en-US" sz="740" dirty="0">
                           <a:solidFill>
                             <a:srgbClr val="5F7183"/>
                           </a:solidFill>
@@ -20509,7 +20619,7 @@
                         </a:rPr>
                         <a:t>熱像</a:t>
                       </a:r>
-                      <a:endParaRPr lang="en-US" sz="1100" dirty="0"/>
+                      <a:endParaRPr lang="en-US" sz="1040" dirty="0"/>
                     </a:p>
                   </a:txBody>
                   <a:tcPr marL="63500" marR="63500" marT="38100" marB="38100" anchor="ctr">
@@ -20560,7 +20670,7 @@
                         <a:buNone/>
                       </a:pPr>
                       <a:r>
-                        <a:rPr lang="en-US" sz="960" dirty="0">
+                        <a:rPr lang="en-US" sz="870" dirty="0">
                           <a:solidFill>
                             <a:srgbClr val="1A2733"/>
                           </a:solidFill>
@@ -20570,14 +20680,14 @@
                         </a:rPr>
                         <a:t>Chênh lệch nhiệt độ</a:t>
                       </a:r>
-                      <a:endParaRPr lang="en-US" sz="1100" dirty="0"/>
-                    </a:p>
-                    <a:p>
-                      <a:pPr algn="l" indent="0" marL="0">
-                        <a:buNone/>
-                      </a:pPr>
-                      <a:r>
-                        <a:rPr lang="en-US" sz="820" dirty="0">
+                      <a:endParaRPr lang="en-US" sz="1040" dirty="0"/>
+                    </a:p>
+                    <a:p>
+                      <a:pPr algn="l" indent="0" marL="0">
+                        <a:buNone/>
+                      </a:pPr>
+                      <a:r>
+                        <a:rPr lang="en-US" sz="740" dirty="0">
                           <a:solidFill>
                             <a:srgbClr val="5F7183"/>
                           </a:solidFill>
@@ -20587,7 +20697,7 @@
                         </a:rPr>
                         <a:t>溫度差</a:t>
                       </a:r>
-                      <a:endParaRPr lang="en-US" sz="1100" dirty="0"/>
+                      <a:endParaRPr lang="en-US" sz="1040" dirty="0"/>
                     </a:p>
                   </a:txBody>
                   <a:tcPr marL="63500" marR="63500" marT="38100" marB="38100" anchor="ctr">
@@ -20638,7 +20748,7 @@
                         <a:buNone/>
                       </a:pPr>
                       <a:r>
-                        <a:rPr lang="en-US" sz="960" dirty="0">
+                        <a:rPr lang="en-US" sz="870" dirty="0">
                           <a:solidFill>
                             <a:srgbClr val="1A2733"/>
                           </a:solidFill>
@@ -20648,7 +20758,7 @@
                         </a:rPr>
                         <a:t>150 m</a:t>
                       </a:r>
-                      <a:endParaRPr lang="en-US" sz="1100" dirty="0"/>
+                      <a:endParaRPr lang="en-US" sz="1040" dirty="0"/>
                     </a:p>
                   </a:txBody>
                   <a:tcPr marL="63500" marR="63500" marT="38100" marB="38100" anchor="ctr">
@@ -20699,7 +20809,7 @@
                         <a:buNone/>
                       </a:pPr>
                       <a:r>
-                        <a:rPr lang="en-US" sz="960" dirty="0">
+                        <a:rPr lang="en-US" sz="870" dirty="0">
                           <a:solidFill>
                             <a:srgbClr val="1A2733"/>
                           </a:solidFill>
@@ -20709,14 +20819,14 @@
                         </a:rPr>
                         <a:t>Độ phân giải thấp</a:t>
                       </a:r>
-                      <a:endParaRPr lang="en-US" sz="1100" dirty="0"/>
-                    </a:p>
-                    <a:p>
-                      <a:pPr algn="l" indent="0" marL="0">
-                        <a:buNone/>
-                      </a:pPr>
-                      <a:r>
-                        <a:rPr lang="en-US" sz="820" dirty="0">
+                      <a:endParaRPr lang="en-US" sz="1040" dirty="0"/>
+                    </a:p>
+                    <a:p>
+                      <a:pPr algn="l" indent="0" marL="0">
+                        <a:buNone/>
+                      </a:pPr>
+                      <a:r>
+                        <a:rPr lang="en-US" sz="740" dirty="0">
                           <a:solidFill>
                             <a:srgbClr val="5F7183"/>
                           </a:solidFill>
@@ -20726,7 +20836,304 @@
                         </a:rPr>
                         <a:t>解析度低</a:t>
                       </a:r>
-                      <a:endParaRPr lang="en-US" sz="1100" dirty="0"/>
+                      <a:endParaRPr lang="en-US" sz="1040" dirty="0"/>
+                    </a:p>
+                  </a:txBody>
+                  <a:tcPr marL="63500" marR="63500" marT="38100" marB="38100" anchor="ctr">
+                    <a:lnL w="6350" cap="flat" cmpd="sng" algn="ctr">
+                      <a:solidFill>
+                        <a:srgbClr val="DBE3EA"/>
+                      </a:solidFill>
+                      <a:prstDash val="solid"/>
+                      <a:round/>
+                      <a:headEnd type="none" w="med" len="med"/>
+                      <a:tailEnd type="none" w="med" len="med"/>
+                    </a:lnL>
+                    <a:lnR w="6350" cap="flat" cmpd="sng" algn="ctr">
+                      <a:solidFill>
+                        <a:srgbClr val="DBE3EA"/>
+                      </a:solidFill>
+                      <a:prstDash val="solid"/>
+                      <a:round/>
+                      <a:headEnd type="none" w="med" len="med"/>
+                      <a:tailEnd type="none" w="med" len="med"/>
+                    </a:lnR>
+                    <a:lnT w="6350" cap="flat" cmpd="sng" algn="ctr">
+                      <a:solidFill>
+                        <a:srgbClr val="DBE3EA"/>
+                      </a:solidFill>
+                      <a:prstDash val="solid"/>
+                      <a:round/>
+                      <a:headEnd type="none" w="med" len="med"/>
+                      <a:tailEnd type="none" w="med" len="med"/>
+                    </a:lnT>
+                    <a:lnB w="6350" cap="flat" cmpd="sng" algn="ctr">
+                      <a:solidFill>
+                        <a:srgbClr val="DBE3EA"/>
+                      </a:solidFill>
+                      <a:prstDash val="solid"/>
+                      <a:round/>
+                      <a:headEnd type="none" w="med" len="med"/>
+                      <a:tailEnd type="none" w="med" len="med"/>
+                    </a:lnB>
+                  </a:tcPr>
+                </a:tc>
+              </a:tr>
+              <a:tr h="261625">
+                <a:tc>
+                  <a:txBody>
+                    <a:bodyPr/>
+                    <a:lstStyle/>
+                    <a:p>
+                      <a:pPr algn="l" indent="0" marL="0">
+                        <a:buNone/>
+                      </a:pPr>
+                      <a:r>
+                        <a:rPr lang="en-US" sz="870" b="1" dirty="0">
+                          <a:solidFill>
+                            <a:srgbClr val="0B1F3A"/>
+                          </a:solidFill>
+                          <a:latin typeface="Arial" pitchFamily="34" charset="0"/>
+                          <a:ea typeface="Arial" pitchFamily="34" charset="-122"/>
+                          <a:cs typeface="Arial" pitchFamily="34" charset="-120"/>
+                        </a:rPr>
+                        <a:t>IMU (tuần 6)</a:t>
+                      </a:r>
+                      <a:endParaRPr lang="en-US" sz="1040" dirty="0"/>
+                    </a:p>
+                    <a:p>
+                      <a:pPr algn="l" indent="0" marL="0">
+                        <a:buNone/>
+                      </a:pPr>
+                      <a:r>
+                        <a:rPr lang="en-US" sz="740" dirty="0">
+                          <a:solidFill>
+                            <a:srgbClr val="5F7183"/>
+                          </a:solidFill>
+                          <a:latin typeface="微軟正黑體" pitchFamily="34" charset="0"/>
+                          <a:ea typeface="微軟正黑體" pitchFamily="34" charset="-122"/>
+                          <a:cs typeface="微軟正黑體" pitchFamily="34" charset="-120"/>
+                        </a:rPr>
+                        <a:t>IMU（第六週）</a:t>
+                      </a:r>
+                      <a:endParaRPr lang="en-US" sz="1040" dirty="0"/>
+                    </a:p>
+                  </a:txBody>
+                  <a:tcPr marL="63500" marR="63500" marT="38100" marB="38100" anchor="ctr">
+                    <a:lnL w="6350" cap="flat" cmpd="sng" algn="ctr">
+                      <a:solidFill>
+                        <a:srgbClr val="DBE3EA"/>
+                      </a:solidFill>
+                      <a:prstDash val="solid"/>
+                      <a:round/>
+                      <a:headEnd type="none" w="med" len="med"/>
+                      <a:tailEnd type="none" w="med" len="med"/>
+                    </a:lnL>
+                    <a:lnR w="6350" cap="flat" cmpd="sng" algn="ctr">
+                      <a:solidFill>
+                        <a:srgbClr val="DBE3EA"/>
+                      </a:solidFill>
+                      <a:prstDash val="solid"/>
+                      <a:round/>
+                      <a:headEnd type="none" w="med" len="med"/>
+                      <a:tailEnd type="none" w="med" len="med"/>
+                    </a:lnR>
+                    <a:lnT w="6350" cap="flat" cmpd="sng" algn="ctr">
+                      <a:solidFill>
+                        <a:srgbClr val="DBE3EA"/>
+                      </a:solidFill>
+                      <a:prstDash val="solid"/>
+                      <a:round/>
+                      <a:headEnd type="none" w="med" len="med"/>
+                      <a:tailEnd type="none" w="med" len="med"/>
+                    </a:lnT>
+                    <a:lnB w="6350" cap="flat" cmpd="sng" algn="ctr">
+                      <a:solidFill>
+                        <a:srgbClr val="DBE3EA"/>
+                      </a:solidFill>
+                      <a:prstDash val="solid"/>
+                      <a:round/>
+                      <a:headEnd type="none" w="med" len="med"/>
+                      <a:tailEnd type="none" w="med" len="med"/>
+                    </a:lnB>
+                  </a:tcPr>
+                </a:tc>
+                <a:tc>
+                  <a:txBody>
+                    <a:bodyPr/>
+                    <a:lstStyle/>
+                    <a:p>
+                      <a:pPr algn="l" indent="0" marL="0">
+                        <a:buNone/>
+                      </a:pPr>
+                      <a:r>
+                        <a:rPr lang="en-US" sz="870" dirty="0">
+                          <a:solidFill>
+                            <a:srgbClr val="1A2733"/>
+                          </a:solidFill>
+                          <a:latin typeface="Arial" pitchFamily="34" charset="0"/>
+                          <a:ea typeface="Arial" pitchFamily="34" charset="-122"/>
+                          <a:cs typeface="Arial" pitchFamily="34" charset="-120"/>
+                        </a:rPr>
+                        <a:t>Gia tốc, tốc độ quay của chính xe</a:t>
+                      </a:r>
+                      <a:endParaRPr lang="en-US" sz="1040" dirty="0"/>
+                    </a:p>
+                    <a:p>
+                      <a:pPr algn="l" indent="0" marL="0">
+                        <a:buNone/>
+                      </a:pPr>
+                      <a:r>
+                        <a:rPr lang="en-US" sz="740" dirty="0">
+                          <a:solidFill>
+                            <a:srgbClr val="5F7183"/>
+                          </a:solidFill>
+                          <a:latin typeface="微軟正黑體" pitchFamily="34" charset="0"/>
+                          <a:ea typeface="微軟正黑體" pitchFamily="34" charset="-122"/>
+                          <a:cs typeface="微軟正黑體" pitchFamily="34" charset="-120"/>
+                        </a:rPr>
+                        <a:t>自己的加速度、轉多快</a:t>
+                      </a:r>
+                      <a:endParaRPr lang="en-US" sz="1040" dirty="0"/>
+                    </a:p>
+                  </a:txBody>
+                  <a:tcPr marL="63500" marR="63500" marT="38100" marB="38100" anchor="ctr">
+                    <a:lnL w="6350" cap="flat" cmpd="sng" algn="ctr">
+                      <a:solidFill>
+                        <a:srgbClr val="DBE3EA"/>
+                      </a:solidFill>
+                      <a:prstDash val="solid"/>
+                      <a:round/>
+                      <a:headEnd type="none" w="med" len="med"/>
+                      <a:tailEnd type="none" w="med" len="med"/>
+                    </a:lnL>
+                    <a:lnR w="6350" cap="flat" cmpd="sng" algn="ctr">
+                      <a:solidFill>
+                        <a:srgbClr val="DBE3EA"/>
+                      </a:solidFill>
+                      <a:prstDash val="solid"/>
+                      <a:round/>
+                      <a:headEnd type="none" w="med" len="med"/>
+                      <a:tailEnd type="none" w="med" len="med"/>
+                    </a:lnR>
+                    <a:lnT w="6350" cap="flat" cmpd="sng" algn="ctr">
+                      <a:solidFill>
+                        <a:srgbClr val="DBE3EA"/>
+                      </a:solidFill>
+                      <a:prstDash val="solid"/>
+                      <a:round/>
+                      <a:headEnd type="none" w="med" len="med"/>
+                      <a:tailEnd type="none" w="med" len="med"/>
+                    </a:lnT>
+                    <a:lnB w="6350" cap="flat" cmpd="sng" algn="ctr">
+                      <a:solidFill>
+                        <a:srgbClr val="DBE3EA"/>
+                      </a:solidFill>
+                      <a:prstDash val="solid"/>
+                      <a:round/>
+                      <a:headEnd type="none" w="med" len="med"/>
+                      <a:tailEnd type="none" w="med" len="med"/>
+                    </a:lnB>
+                  </a:tcPr>
+                </a:tc>
+                <a:tc>
+                  <a:txBody>
+                    <a:bodyPr/>
+                    <a:lstStyle/>
+                    <a:p>
+                      <a:pPr algn="l" indent="0" marL="0">
+                        <a:buNone/>
+                      </a:pPr>
+                      <a:r>
+                        <a:rPr lang="en-US" sz="870" dirty="0">
+                          <a:solidFill>
+                            <a:srgbClr val="1A2733"/>
+                          </a:solidFill>
+                          <a:latin typeface="Arial" pitchFamily="34" charset="0"/>
+                          <a:ea typeface="Arial" pitchFamily="34" charset="-122"/>
+                          <a:cs typeface="Arial" pitchFamily="34" charset="-120"/>
+                        </a:rPr>
+                        <a:t>—</a:t>
+                      </a:r>
+                      <a:endParaRPr lang="en-US" sz="1040" dirty="0"/>
+                    </a:p>
+                  </a:txBody>
+                  <a:tcPr marL="63500" marR="63500" marT="38100" marB="38100" anchor="ctr">
+                    <a:lnL w="6350" cap="flat" cmpd="sng" algn="ctr">
+                      <a:solidFill>
+                        <a:srgbClr val="DBE3EA"/>
+                      </a:solidFill>
+                      <a:prstDash val="solid"/>
+                      <a:round/>
+                      <a:headEnd type="none" w="med" len="med"/>
+                      <a:tailEnd type="none" w="med" len="med"/>
+                    </a:lnL>
+                    <a:lnR w="6350" cap="flat" cmpd="sng" algn="ctr">
+                      <a:solidFill>
+                        <a:srgbClr val="DBE3EA"/>
+                      </a:solidFill>
+                      <a:prstDash val="solid"/>
+                      <a:round/>
+                      <a:headEnd type="none" w="med" len="med"/>
+                      <a:tailEnd type="none" w="med" len="med"/>
+                    </a:lnR>
+                    <a:lnT w="6350" cap="flat" cmpd="sng" algn="ctr">
+                      <a:solidFill>
+                        <a:srgbClr val="DBE3EA"/>
+                      </a:solidFill>
+                      <a:prstDash val="solid"/>
+                      <a:round/>
+                      <a:headEnd type="none" w="med" len="med"/>
+                      <a:tailEnd type="none" w="med" len="med"/>
+                    </a:lnT>
+                    <a:lnB w="6350" cap="flat" cmpd="sng" algn="ctr">
+                      <a:solidFill>
+                        <a:srgbClr val="DBE3EA"/>
+                      </a:solidFill>
+                      <a:prstDash val="solid"/>
+                      <a:round/>
+                      <a:headEnd type="none" w="med" len="med"/>
+                      <a:tailEnd type="none" w="med" len="med"/>
+                    </a:lnB>
+                  </a:tcPr>
+                </a:tc>
+                <a:tc>
+                  <a:txBody>
+                    <a:bodyPr/>
+                    <a:lstStyle/>
+                    <a:p>
+                      <a:pPr algn="l" indent="0" marL="0">
+                        <a:buNone/>
+                      </a:pPr>
+                      <a:r>
+                        <a:rPr lang="en-US" sz="870" dirty="0">
+                          <a:solidFill>
+                            <a:srgbClr val="1A2733"/>
+                          </a:solidFill>
+                          <a:latin typeface="Arial" pitchFamily="34" charset="0"/>
+                          <a:ea typeface="Arial" pitchFamily="34" charset="-122"/>
+                          <a:cs typeface="Arial" pitchFamily="34" charset="-120"/>
+                        </a:rPr>
+                        <a:t>Trôi: sai số tăng theo t²</a:t>
+                      </a:r>
+                      <a:endParaRPr lang="en-US" sz="1040" dirty="0"/>
+                    </a:p>
+                    <a:p>
+                      <a:pPr algn="l" indent="0" marL="0">
+                        <a:buNone/>
+                      </a:pPr>
+                      <a:r>
+                        <a:rPr lang="en-US" sz="740" dirty="0">
+                          <a:solidFill>
+                            <a:srgbClr val="5F7183"/>
+                          </a:solidFill>
+                          <a:latin typeface="微軟正黑體" pitchFamily="34" charset="0"/>
+                          <a:ea typeface="微軟正黑體" pitchFamily="34" charset="-122"/>
+                          <a:cs typeface="微軟正黑體" pitchFamily="34" charset="-120"/>
+                        </a:rPr>
+                        <a:t>會漂移：誤差跟 t² 變大</a:t>
+                      </a:r>
+                      <a:endParaRPr lang="en-US" sz="1040" dirty="0"/>
                     </a:p>
                   </a:txBody>
                   <a:tcPr marL="63500" marR="63500" marT="38100" marB="38100" anchor="ctr">
@@ -20781,8 +21188,8 @@
         </p:nvSpPr>
         <p:spPr>
           <a:xfrm>
-            <a:off x="849794" y="4210925"/>
-            <a:ext cx="7444411" cy="418225"/>
+            <a:off x="1044024" y="4232748"/>
+            <a:ext cx="7055952" cy="396402"/>
           </a:xfrm>
           <a:prstGeom prst="rect">
             <a:avLst/>
@@ -20801,7 +21208,7 @@
               <a:buNone/>
             </a:pPr>
             <a:r>
-              <a:rPr lang="en-US" sz="1100" b="1" dirty="0">
+              <a:rPr lang="en-US" sz="1040" b="1" dirty="0">
                 <a:solidFill>
                   <a:srgbClr val="007F72"/>
                 </a:solidFill>
@@ -20811,7 +21218,7 @@
               </a:rPr>
               <a:t>Đo được khoảng cách ≠ biết là gì. Chỉ camera đọc được màu đèn giao thông.</a:t>
             </a:r>
-            <a:endParaRPr lang="en-US" sz="1100" dirty="0"/>
+            <a:endParaRPr lang="en-US" sz="1040" dirty="0"/>
           </a:p>
           <a:p>
             <a:pPr indent="0" marL="0">
@@ -20821,7 +21228,7 @@
               <a:buNone/>
             </a:pPr>
             <a:r>
-              <a:rPr lang="en-US" sz="1010" dirty="0">
+              <a:rPr lang="en-US" sz="950" dirty="0">
                 <a:solidFill>
                   <a:srgbClr val="007F72"/>
                 </a:solidFill>
@@ -20831,7 +21238,7 @@
               </a:rPr>
               <a:t>量得到距離≠知道是什麼。只有相機讀得出紅綠燈的顏色。</a:t>
             </a:r>
-            <a:endParaRPr lang="en-US" sz="1100" dirty="0"/>
+            <a:endParaRPr lang="en-US" sz="1040" dirty="0"/>
           </a:p>
         </p:txBody>
       </p:sp>
@@ -20867,8 +21274,8 @@
         </p:nvSpPr>
         <p:spPr>
           <a:xfrm>
-            <a:off x="490121" y="117103"/>
-            <a:ext cx="752806" cy="234206"/>
+            <a:off x="703119" y="110992"/>
+            <a:ext cx="713523" cy="221985"/>
           </a:xfrm>
           <a:prstGeom prst="rect">
             <a:avLst/>
@@ -20884,7 +21291,7 @@
               <a:buNone/>
             </a:pPr>
             <a:r>
-              <a:rPr lang="en-US" sz="820" dirty="0">
+              <a:rPr lang="en-US" sz="780" dirty="0">
                 <a:solidFill>
                   <a:srgbClr val="5F7183"/>
                 </a:solidFill>
@@ -20894,7 +21301,7 @@
               </a:rPr>
               <a:t>6 / 15</a:t>
             </a:r>
-            <a:endParaRPr lang="en-US" sz="820" dirty="0"/>
+            <a:endParaRPr lang="en-US" sz="780" dirty="0"/>
           </a:p>
         </p:txBody>
       </p:sp>
@@ -20906,8 +21313,8 @@
         </p:nvSpPr>
         <p:spPr>
           <a:xfrm>
-            <a:off x="1268020" y="117103"/>
-            <a:ext cx="1840192" cy="234206"/>
+            <a:off x="1440426" y="110992"/>
+            <a:ext cx="1744168" cy="221985"/>
           </a:xfrm>
           <a:prstGeom prst="rect">
             <a:avLst/>
@@ -20923,7 +21330,7 @@
               <a:buNone/>
             </a:pPr>
             <a:r>
-              <a:rPr lang="en-US" sz="820" dirty="0">
+              <a:rPr lang="en-US" sz="780" dirty="0">
                 <a:solidFill>
                   <a:srgbClr val="5F7183"/>
                 </a:solidFill>
@@ -20933,7 +21340,7 @@
               </a:rPr>
               <a:t>Tiết 3 · 第 3 節</a:t>
             </a:r>
-            <a:endParaRPr lang="en-US" sz="820" dirty="0"/>
+            <a:endParaRPr lang="en-US" sz="780" dirty="0"/>
           </a:p>
         </p:txBody>
       </p:sp>

</xml_diff>